<commit_message>
Brand Integration: New official shield logo, saffron-green colorway, and high-res Android splash screens
</commit_message>
<xml_diff>
--- a/Project Docs/KisanKavach_SLBC_Anchor_Presentation.pptx
+++ b/Project Docs/KisanKavach_SLBC_Anchor_Presentation.pptx
@@ -5,20 +5,20 @@
     <p:sldMasterId id="2147483648" r:id="rId1"/>
   </p:sldMasterIdLst>
   <p:sldIdLst>
-    <p:sldId id="256" r:id="rId7"/>
-    <p:sldId id="257" r:id="rId8"/>
-    <p:sldId id="258" r:id="rId9"/>
-    <p:sldId id="259" r:id="rId10"/>
-    <p:sldId id="260" r:id="rId11"/>
-    <p:sldId id="261" r:id="rId12"/>
-    <p:sldId id="262" r:id="rId13"/>
-    <p:sldId id="263" r:id="rId14"/>
-    <p:sldId id="264" r:id="rId15"/>
-    <p:sldId id="265" r:id="rId16"/>
-    <p:sldId id="266" r:id="rId17"/>
-    <p:sldId id="267" r:id="rId18"/>
+    <p:sldId id="256" r:id="rId2"/>
+    <p:sldId id="257" r:id="rId3"/>
+    <p:sldId id="258" r:id="rId4"/>
+    <p:sldId id="259" r:id="rId5"/>
+    <p:sldId id="260" r:id="rId6"/>
+    <p:sldId id="261" r:id="rId7"/>
+    <p:sldId id="262" r:id="rId8"/>
+    <p:sldId id="263" r:id="rId9"/>
+    <p:sldId id="264" r:id="rId10"/>
+    <p:sldId id="265" r:id="rId11"/>
+    <p:sldId id="266" r:id="rId12"/>
+    <p:sldId id="267" r:id="rId13"/>
   </p:sldIdLst>
-  <p:sldSz cx="12191695" cy="6858000" type="screen4x3"/>
+  <p:sldSz cx="12192000" cy="6858000"/>
   <p:notesSz cx="6858000" cy="9144000"/>
   <p:defaultTextStyle>
     <a:defPPr>
@@ -299,7 +299,8 @@
           <a:p>
             <a:fld id="{5BCAD085-E8A6-8845-BD4E-CB4CCA059FC4}" type="datetimeFigureOut">
               <a:rPr lang="en-US" smtClean="0"/>
-              <a:t>1/27/13</a:t>
+              <a:pPr/>
+              <a:t>9/16/2026</a:t>
             </a:fld>
             <a:endParaRPr lang="en-US"/>
           </a:p>
@@ -341,6 +342,7 @@
           <a:p>
             <a:fld id="{C1FF6DA9-008F-8B48-92A6-B652298478BF}" type="slidenum">
               <a:rPr lang="en-US" smtClean="0"/>
+              <a:pPr/>
               <a:t>‹#›</a:t>
             </a:fld>
             <a:endParaRPr lang="en-US"/>
@@ -350,7 +352,7 @@
     </p:spTree>
     <p:extLst>
       <p:ext uri="{BB962C8B-B14F-4D97-AF65-F5344CB8AC3E}">
-        <p14:creationId xmlns:p14="http://schemas.microsoft.com/office/powerpoint/2010/main" val="3168075583"/>
+        <p14:creationId xmlns:p14="http://schemas.microsoft.com/office/powerpoint/2010/main" xmlns="" val="3168075583"/>
       </p:ext>
     </p:extLst>
   </p:cSld>
@@ -469,7 +471,8 @@
           <a:p>
             <a:fld id="{5BCAD085-E8A6-8845-BD4E-CB4CCA059FC4}" type="datetimeFigureOut">
               <a:rPr lang="en-US" smtClean="0"/>
-              <a:t>1/27/13</a:t>
+              <a:pPr/>
+              <a:t>9/16/2026</a:t>
             </a:fld>
             <a:endParaRPr lang="en-US"/>
           </a:p>
@@ -511,6 +514,7 @@
           <a:p>
             <a:fld id="{C1FF6DA9-008F-8B48-92A6-B652298478BF}" type="slidenum">
               <a:rPr lang="en-US" smtClean="0"/>
+              <a:pPr/>
               <a:t>‹#›</a:t>
             </a:fld>
             <a:endParaRPr lang="en-US"/>
@@ -520,7 +524,7 @@
     </p:spTree>
     <p:extLst>
       <p:ext uri="{BB962C8B-B14F-4D97-AF65-F5344CB8AC3E}">
-        <p14:creationId xmlns:p14="http://schemas.microsoft.com/office/powerpoint/2010/main" val="2910927964"/>
+        <p14:creationId xmlns:p14="http://schemas.microsoft.com/office/powerpoint/2010/main" xmlns="" val="2910927964"/>
       </p:ext>
     </p:extLst>
   </p:cSld>
@@ -649,7 +653,8 @@
           <a:p>
             <a:fld id="{5BCAD085-E8A6-8845-BD4E-CB4CCA059FC4}" type="datetimeFigureOut">
               <a:rPr lang="en-US" smtClean="0"/>
-              <a:t>1/27/13</a:t>
+              <a:pPr/>
+              <a:t>9/16/2026</a:t>
             </a:fld>
             <a:endParaRPr lang="en-US"/>
           </a:p>
@@ -691,6 +696,7 @@
           <a:p>
             <a:fld id="{C1FF6DA9-008F-8B48-92A6-B652298478BF}" type="slidenum">
               <a:rPr lang="en-US" smtClean="0"/>
+              <a:pPr/>
               <a:t>‹#›</a:t>
             </a:fld>
             <a:endParaRPr lang="en-US"/>
@@ -700,7 +706,7 @@
     </p:spTree>
     <p:extLst>
       <p:ext uri="{BB962C8B-B14F-4D97-AF65-F5344CB8AC3E}">
-        <p14:creationId xmlns:p14="http://schemas.microsoft.com/office/powerpoint/2010/main" val="3612223792"/>
+        <p14:creationId xmlns:p14="http://schemas.microsoft.com/office/powerpoint/2010/main" xmlns="" val="3612223792"/>
       </p:ext>
     </p:extLst>
   </p:cSld>
@@ -819,7 +825,8 @@
           <a:p>
             <a:fld id="{5BCAD085-E8A6-8845-BD4E-CB4CCA059FC4}" type="datetimeFigureOut">
               <a:rPr lang="en-US" smtClean="0"/>
-              <a:t>1/27/13</a:t>
+              <a:pPr/>
+              <a:t>9/16/2026</a:t>
             </a:fld>
             <a:endParaRPr lang="en-US"/>
           </a:p>
@@ -861,6 +868,7 @@
           <a:p>
             <a:fld id="{C1FF6DA9-008F-8B48-92A6-B652298478BF}" type="slidenum">
               <a:rPr lang="en-US" smtClean="0"/>
+              <a:pPr/>
               <a:t>‹#›</a:t>
             </a:fld>
             <a:endParaRPr lang="en-US"/>
@@ -870,7 +878,7 @@
     </p:spTree>
     <p:extLst>
       <p:ext uri="{BB962C8B-B14F-4D97-AF65-F5344CB8AC3E}">
-        <p14:creationId xmlns:p14="http://schemas.microsoft.com/office/powerpoint/2010/main" val="2614314258"/>
+        <p14:creationId xmlns:p14="http://schemas.microsoft.com/office/powerpoint/2010/main" xmlns="" val="2614314258"/>
       </p:ext>
     </p:extLst>
   </p:cSld>
@@ -1065,7 +1073,8 @@
           <a:p>
             <a:fld id="{5BCAD085-E8A6-8845-BD4E-CB4CCA059FC4}" type="datetimeFigureOut">
               <a:rPr lang="en-US" smtClean="0"/>
-              <a:t>1/27/13</a:t>
+              <a:pPr/>
+              <a:t>9/16/2026</a:t>
             </a:fld>
             <a:endParaRPr lang="en-US"/>
           </a:p>
@@ -1107,6 +1116,7 @@
           <a:p>
             <a:fld id="{C1FF6DA9-008F-8B48-92A6-B652298478BF}" type="slidenum">
               <a:rPr lang="en-US" smtClean="0"/>
+              <a:pPr/>
               <a:t>‹#›</a:t>
             </a:fld>
             <a:endParaRPr lang="en-US"/>
@@ -1116,7 +1126,7 @@
     </p:spTree>
     <p:extLst>
       <p:ext uri="{BB962C8B-B14F-4D97-AF65-F5344CB8AC3E}">
-        <p14:creationId xmlns:p14="http://schemas.microsoft.com/office/powerpoint/2010/main" val="960648375"/>
+        <p14:creationId xmlns:p14="http://schemas.microsoft.com/office/powerpoint/2010/main" xmlns="" val="960648375"/>
       </p:ext>
     </p:extLst>
   </p:cSld>
@@ -1353,7 +1363,8 @@
           <a:p>
             <a:fld id="{5BCAD085-E8A6-8845-BD4E-CB4CCA059FC4}" type="datetimeFigureOut">
               <a:rPr lang="en-US" smtClean="0"/>
-              <a:t>1/27/13</a:t>
+              <a:pPr/>
+              <a:t>9/16/2026</a:t>
             </a:fld>
             <a:endParaRPr lang="en-US"/>
           </a:p>
@@ -1395,6 +1406,7 @@
           <a:p>
             <a:fld id="{C1FF6DA9-008F-8B48-92A6-B652298478BF}" type="slidenum">
               <a:rPr lang="en-US" smtClean="0"/>
+              <a:pPr/>
               <a:t>‹#›</a:t>
             </a:fld>
             <a:endParaRPr lang="en-US"/>
@@ -1404,7 +1416,7 @@
     </p:spTree>
     <p:extLst>
       <p:ext uri="{BB962C8B-B14F-4D97-AF65-F5344CB8AC3E}">
-        <p14:creationId xmlns:p14="http://schemas.microsoft.com/office/powerpoint/2010/main" val="2782244947"/>
+        <p14:creationId xmlns:p14="http://schemas.microsoft.com/office/powerpoint/2010/main" xmlns="" val="2782244947"/>
       </p:ext>
     </p:extLst>
   </p:cSld>
@@ -1775,7 +1787,8 @@
           <a:p>
             <a:fld id="{5BCAD085-E8A6-8845-BD4E-CB4CCA059FC4}" type="datetimeFigureOut">
               <a:rPr lang="en-US" smtClean="0"/>
-              <a:t>1/27/13</a:t>
+              <a:pPr/>
+              <a:t>9/16/2026</a:t>
             </a:fld>
             <a:endParaRPr lang="en-US"/>
           </a:p>
@@ -1817,6 +1830,7 @@
           <a:p>
             <a:fld id="{C1FF6DA9-008F-8B48-92A6-B652298478BF}" type="slidenum">
               <a:rPr lang="en-US" smtClean="0"/>
+              <a:pPr/>
               <a:t>‹#›</a:t>
             </a:fld>
             <a:endParaRPr lang="en-US"/>
@@ -1826,7 +1840,7 @@
     </p:spTree>
     <p:extLst>
       <p:ext uri="{BB962C8B-B14F-4D97-AF65-F5344CB8AC3E}">
-        <p14:creationId xmlns:p14="http://schemas.microsoft.com/office/powerpoint/2010/main" val="990158736"/>
+        <p14:creationId xmlns:p14="http://schemas.microsoft.com/office/powerpoint/2010/main" xmlns="" val="990158736"/>
       </p:ext>
     </p:extLst>
   </p:cSld>
@@ -1893,7 +1907,8 @@
           <a:p>
             <a:fld id="{5BCAD085-E8A6-8845-BD4E-CB4CCA059FC4}" type="datetimeFigureOut">
               <a:rPr lang="en-US" smtClean="0"/>
-              <a:t>1/27/13</a:t>
+              <a:pPr/>
+              <a:t>9/16/2026</a:t>
             </a:fld>
             <a:endParaRPr lang="en-US"/>
           </a:p>
@@ -1935,6 +1950,7 @@
           <a:p>
             <a:fld id="{C1FF6DA9-008F-8B48-92A6-B652298478BF}" type="slidenum">
               <a:rPr lang="en-US" smtClean="0"/>
+              <a:pPr/>
               <a:t>‹#›</a:t>
             </a:fld>
             <a:endParaRPr lang="en-US"/>
@@ -1944,7 +1960,7 @@
     </p:spTree>
     <p:extLst>
       <p:ext uri="{BB962C8B-B14F-4D97-AF65-F5344CB8AC3E}">
-        <p14:creationId xmlns:p14="http://schemas.microsoft.com/office/powerpoint/2010/main" val="727027711"/>
+        <p14:creationId xmlns:p14="http://schemas.microsoft.com/office/powerpoint/2010/main" xmlns="" val="727027711"/>
       </p:ext>
     </p:extLst>
   </p:cSld>
@@ -1988,7 +2004,8 @@
           <a:p>
             <a:fld id="{5BCAD085-E8A6-8845-BD4E-CB4CCA059FC4}" type="datetimeFigureOut">
               <a:rPr lang="en-US" smtClean="0"/>
-              <a:t>1/27/13</a:t>
+              <a:pPr/>
+              <a:t>9/16/2026</a:t>
             </a:fld>
             <a:endParaRPr lang="en-US"/>
           </a:p>
@@ -2030,6 +2047,7 @@
           <a:p>
             <a:fld id="{C1FF6DA9-008F-8B48-92A6-B652298478BF}" type="slidenum">
               <a:rPr lang="en-US" smtClean="0"/>
+              <a:pPr/>
               <a:t>‹#›</a:t>
             </a:fld>
             <a:endParaRPr lang="en-US"/>
@@ -2039,7 +2057,7 @@
     </p:spTree>
     <p:extLst>
       <p:ext uri="{BB962C8B-B14F-4D97-AF65-F5344CB8AC3E}">
-        <p14:creationId xmlns:p14="http://schemas.microsoft.com/office/powerpoint/2010/main" val="1212999818"/>
+        <p14:creationId xmlns:p14="http://schemas.microsoft.com/office/powerpoint/2010/main" xmlns="" val="1212999818"/>
       </p:ext>
     </p:extLst>
   </p:cSld>
@@ -2265,7 +2283,8 @@
           <a:p>
             <a:fld id="{5BCAD085-E8A6-8845-BD4E-CB4CCA059FC4}" type="datetimeFigureOut">
               <a:rPr lang="en-US" smtClean="0"/>
-              <a:t>1/27/13</a:t>
+              <a:pPr/>
+              <a:t>9/16/2026</a:t>
             </a:fld>
             <a:endParaRPr lang="en-US"/>
           </a:p>
@@ -2307,6 +2326,7 @@
           <a:p>
             <a:fld id="{C1FF6DA9-008F-8B48-92A6-B652298478BF}" type="slidenum">
               <a:rPr lang="en-US" smtClean="0"/>
+              <a:pPr/>
               <a:t>‹#›</a:t>
             </a:fld>
             <a:endParaRPr lang="en-US"/>
@@ -2316,7 +2336,7 @@
     </p:spTree>
     <p:extLst>
       <p:ext uri="{BB962C8B-B14F-4D97-AF65-F5344CB8AC3E}">
-        <p14:creationId xmlns:p14="http://schemas.microsoft.com/office/powerpoint/2010/main" val="1840726560"/>
+        <p14:creationId xmlns:p14="http://schemas.microsoft.com/office/powerpoint/2010/main" xmlns="" val="1840726560"/>
       </p:ext>
     </p:extLst>
   </p:cSld>
@@ -2518,7 +2538,8 @@
           <a:p>
             <a:fld id="{5BCAD085-E8A6-8845-BD4E-CB4CCA059FC4}" type="datetimeFigureOut">
               <a:rPr lang="en-US" smtClean="0"/>
-              <a:t>1/27/13</a:t>
+              <a:pPr/>
+              <a:t>9/16/2026</a:t>
             </a:fld>
             <a:endParaRPr lang="en-US"/>
           </a:p>
@@ -2560,6 +2581,7 @@
           <a:p>
             <a:fld id="{C1FF6DA9-008F-8B48-92A6-B652298478BF}" type="slidenum">
               <a:rPr lang="en-US" smtClean="0"/>
+              <a:pPr/>
               <a:t>‹#›</a:t>
             </a:fld>
             <a:endParaRPr lang="en-US"/>
@@ -2569,7 +2591,7 @@
     </p:spTree>
     <p:extLst>
       <p:ext uri="{BB962C8B-B14F-4D97-AF65-F5344CB8AC3E}">
-        <p14:creationId xmlns:p14="http://schemas.microsoft.com/office/powerpoint/2010/main" val="3889236939"/>
+        <p14:creationId xmlns:p14="http://schemas.microsoft.com/office/powerpoint/2010/main" xmlns="" val="3889236939"/>
       </p:ext>
     </p:extLst>
   </p:cSld>
@@ -2731,7 +2753,8 @@
           <a:p>
             <a:fld id="{5BCAD085-E8A6-8845-BD4E-CB4CCA059FC4}" type="datetimeFigureOut">
               <a:rPr lang="en-US" smtClean="0"/>
-              <a:t>1/27/13</a:t>
+              <a:pPr/>
+              <a:t>9/16/2026</a:t>
             </a:fld>
             <a:endParaRPr lang="en-US"/>
           </a:p>
@@ -2809,6 +2832,7 @@
           <a:p>
             <a:fld id="{C1FF6DA9-008F-8B48-92A6-B652298478BF}" type="slidenum">
               <a:rPr lang="en-US" smtClean="0"/>
+              <a:pPr/>
               <a:t>‹#›</a:t>
             </a:fld>
             <a:endParaRPr lang="en-US"/>
@@ -2818,7 +2842,7 @@
     </p:spTree>
     <p:extLst>
       <p:ext uri="{BB962C8B-B14F-4D97-AF65-F5344CB8AC3E}">
-        <p14:creationId xmlns:p14="http://schemas.microsoft.com/office/powerpoint/2010/main" val="2209977519"/>
+        <p14:creationId xmlns:p14="http://schemas.microsoft.com/office/powerpoint/2010/main" xmlns="" val="2209977519"/>
       </p:ext>
     </p:extLst>
   </p:cSld>
@@ -3090,7 +3114,7 @@
 </file>
 
 <file path=ppt/slides/slide1.xml><?xml version="1.0" encoding="utf-8"?>
-<p:sld xmlns:a="http://schemas.openxmlformats.org/drawingml/2006/main" xmlns:p="http://schemas.openxmlformats.org/presentationml/2006/main" xmlns:r="http://schemas.openxmlformats.org/officeDocument/2006/relationships">
+<p:sld xmlns:a="http://schemas.openxmlformats.org/drawingml/2006/main" xmlns:r="http://schemas.openxmlformats.org/officeDocument/2006/relationships" xmlns:p="http://schemas.openxmlformats.org/presentationml/2006/main">
   <p:cSld>
     <p:spTree>
       <p:nvGrpSpPr>
@@ -3098,7 +3122,14 @@
         <p:cNvGrpSpPr/>
         <p:nvPr/>
       </p:nvGrpSpPr>
-      <p:grpSpPr/>
+      <p:grpSpPr>
+        <a:xfrm>
+          <a:off x="0" y="0"/>
+          <a:ext cx="0" cy="0"/>
+          <a:chOff x="0" y="0"/>
+          <a:chExt cx="0" cy="0"/>
+        </a:xfrm>
+      </p:grpSpPr>
       <p:sp>
         <p:nvSpPr>
           <p:cNvPr id="2" name="Rectangle 1"/>
@@ -3139,6 +3170,7 @@
           <a:lstStyle/>
           <a:p>
             <a:pPr algn="ctr"/>
+            <a:endParaRPr/>
           </a:p>
         </p:txBody>
       </p:sp>
@@ -3182,6 +3214,7 @@
           <a:lstStyle/>
           <a:p>
             <a:pPr algn="ctr"/>
+            <a:endParaRPr/>
           </a:p>
         </p:txBody>
       </p:sp>
@@ -3310,6 +3343,7 @@
           <a:lstStyle/>
           <a:p>
             <a:pPr algn="ctr"/>
+            <a:endParaRPr/>
           </a:p>
         </p:txBody>
       </p:sp>
@@ -3336,7 +3370,7 @@
           <a:lstStyle/>
           <a:p>
             <a:r>
-              <a:rPr b="1" sz="1100">
+              <a:rPr sz="1100" b="1">
                 <a:solidFill>
                   <a:srgbClr val="EA580C"/>
                 </a:solidFill>
@@ -3354,7 +3388,7 @@
           </a:p>
           <a:p>
             <a:r>
-              <a:rPr b="1" sz="1100">
+              <a:rPr sz="1100" b="1">
                 <a:solidFill>
                   <a:srgbClr val="EA580C"/>
                 </a:solidFill>
@@ -3372,7 +3406,7 @@
           </a:p>
           <a:p>
             <a:r>
-              <a:rPr b="1" sz="1100">
+              <a:rPr sz="1100" b="1">
                 <a:solidFill>
                   <a:srgbClr val="EA580C"/>
                 </a:solidFill>
@@ -3390,7 +3424,7 @@
           </a:p>
           <a:p>
             <a:r>
-              <a:rPr b="1" sz="1100">
+              <a:rPr sz="1100" b="1">
                 <a:solidFill>
                   <a:srgbClr val="EA580C"/>
                 </a:solidFill>
@@ -3408,7 +3442,7 @@
           </a:p>
           <a:p>
             <a:r>
-              <a:rPr b="1" sz="1100">
+              <a:rPr sz="1100" b="1">
                 <a:solidFill>
                   <a:srgbClr val="EA580C"/>
                 </a:solidFill>
@@ -3431,11 +3465,18 @@
   <p:clrMapOvr>
     <a:masterClrMapping/>
   </p:clrMapOvr>
+  <p:timing>
+    <p:tnLst>
+      <p:par>
+        <p:cTn id="1" dur="indefinite" restart="never" nodeType="tmRoot"/>
+      </p:par>
+    </p:tnLst>
+  </p:timing>
 </p:sld>
 </file>
 
 <file path=ppt/slides/slide10.xml><?xml version="1.0" encoding="utf-8"?>
-<p:sld xmlns:a="http://schemas.openxmlformats.org/drawingml/2006/main" xmlns:p="http://schemas.openxmlformats.org/presentationml/2006/main" xmlns:r="http://schemas.openxmlformats.org/officeDocument/2006/relationships">
+<p:sld xmlns:a="http://schemas.openxmlformats.org/drawingml/2006/main" xmlns:r="http://schemas.openxmlformats.org/officeDocument/2006/relationships" xmlns:p="http://schemas.openxmlformats.org/presentationml/2006/main">
   <p:cSld>
     <p:spTree>
       <p:nvGrpSpPr>
@@ -3443,7 +3484,14 @@
         <p:cNvGrpSpPr/>
         <p:nvPr/>
       </p:nvGrpSpPr>
-      <p:grpSpPr/>
+      <p:grpSpPr>
+        <a:xfrm>
+          <a:off x="0" y="0"/>
+          <a:ext cx="0" cy="0"/>
+          <a:chOff x="0" y="0"/>
+          <a:chExt cx="0" cy="0"/>
+        </a:xfrm>
+      </p:grpSpPr>
       <p:sp>
         <p:nvSpPr>
           <p:cNvPr id="2" name="Rectangle 1"/>
@@ -3484,6 +3532,7 @@
           <a:lstStyle/>
           <a:p>
             <a:pPr algn="ctr"/>
+            <a:endParaRPr/>
           </a:p>
         </p:txBody>
       </p:sp>
@@ -3634,6 +3683,7 @@
           <a:lstStyle/>
           <a:p>
             <a:pPr algn="ctr"/>
+            <a:endParaRPr/>
           </a:p>
         </p:txBody>
       </p:sp>
@@ -3749,6 +3799,7 @@
           <a:lstStyle/>
           <a:p>
             <a:pPr algn="ctr"/>
+            <a:endParaRPr/>
           </a:p>
         </p:txBody>
       </p:sp>
@@ -3792,6 +3843,7 @@
           <a:lstStyle/>
           <a:p>
             <a:pPr algn="ctr"/>
+            <a:endParaRPr/>
           </a:p>
         </p:txBody>
       </p:sp>
@@ -3818,7 +3870,7 @@
           <a:lstStyle/>
           <a:p>
             <a:pPr algn="ctr">
-              <a:defRPr b="1" sz="1000">
+              <a:defRPr sz="1000" b="1">
                 <a:solidFill>
                   <a:srgbClr val="FFFFFF"/>
                 </a:solidFill>
@@ -4009,6 +4061,7 @@
           <a:lstStyle/>
           <a:p>
             <a:pPr algn="ctr"/>
+            <a:endParaRPr/>
           </a:p>
         </p:txBody>
       </p:sp>
@@ -4052,6 +4105,7 @@
           <a:lstStyle/>
           <a:p>
             <a:pPr algn="ctr"/>
+            <a:endParaRPr/>
           </a:p>
         </p:txBody>
       </p:sp>
@@ -4078,7 +4132,7 @@
           <a:lstStyle/>
           <a:p>
             <a:pPr algn="ctr">
-              <a:defRPr b="1" sz="1000">
+              <a:defRPr sz="1000" b="1">
                 <a:solidFill>
                   <a:srgbClr val="FFFFFF"/>
                 </a:solidFill>
@@ -4269,6 +4323,7 @@
           <a:lstStyle/>
           <a:p>
             <a:pPr algn="ctr"/>
+            <a:endParaRPr/>
           </a:p>
         </p:txBody>
       </p:sp>
@@ -4312,6 +4367,7 @@
           <a:lstStyle/>
           <a:p>
             <a:pPr algn="ctr"/>
+            <a:endParaRPr/>
           </a:p>
         </p:txBody>
       </p:sp>
@@ -4338,7 +4394,7 @@
           <a:lstStyle/>
           <a:p>
             <a:pPr algn="ctr">
-              <a:defRPr b="1" sz="1000">
+              <a:defRPr sz="1000" b="1">
                 <a:solidFill>
                   <a:srgbClr val="FFFFFF"/>
                 </a:solidFill>
@@ -4529,6 +4585,7 @@
           <a:lstStyle/>
           <a:p>
             <a:pPr algn="ctr"/>
+            <a:endParaRPr/>
           </a:p>
         </p:txBody>
       </p:sp>
@@ -4572,6 +4629,7 @@
           <a:lstStyle/>
           <a:p>
             <a:pPr algn="ctr"/>
+            <a:endParaRPr/>
           </a:p>
         </p:txBody>
       </p:sp>
@@ -4598,7 +4656,7 @@
           <a:lstStyle/>
           <a:p>
             <a:pPr algn="ctr">
-              <a:defRPr b="1" sz="1000">
+              <a:defRPr sz="1000" b="1">
                 <a:solidFill>
                   <a:srgbClr val="FFFFFF"/>
                 </a:solidFill>
@@ -4752,11 +4810,18 @@
   <p:clrMapOvr>
     <a:masterClrMapping/>
   </p:clrMapOvr>
+  <p:timing>
+    <p:tnLst>
+      <p:par>
+        <p:cTn id="1" dur="indefinite" restart="never" nodeType="tmRoot"/>
+      </p:par>
+    </p:tnLst>
+  </p:timing>
 </p:sld>
 </file>
 
 <file path=ppt/slides/slide11.xml><?xml version="1.0" encoding="utf-8"?>
-<p:sld xmlns:a="http://schemas.openxmlformats.org/drawingml/2006/main" xmlns:p="http://schemas.openxmlformats.org/presentationml/2006/main" xmlns:r="http://schemas.openxmlformats.org/officeDocument/2006/relationships">
+<p:sld xmlns:a="http://schemas.openxmlformats.org/drawingml/2006/main" xmlns:r="http://schemas.openxmlformats.org/officeDocument/2006/relationships" xmlns:p="http://schemas.openxmlformats.org/presentationml/2006/main">
   <p:cSld>
     <p:spTree>
       <p:nvGrpSpPr>
@@ -4764,7 +4829,14 @@
         <p:cNvGrpSpPr/>
         <p:nvPr/>
       </p:nvGrpSpPr>
-      <p:grpSpPr/>
+      <p:grpSpPr>
+        <a:xfrm>
+          <a:off x="0" y="0"/>
+          <a:ext cx="0" cy="0"/>
+          <a:chOff x="0" y="0"/>
+          <a:chExt cx="0" cy="0"/>
+        </a:xfrm>
+      </p:grpSpPr>
       <p:sp>
         <p:nvSpPr>
           <p:cNvPr id="2" name="Rectangle 1"/>
@@ -4805,6 +4877,7 @@
           <a:lstStyle/>
           <a:p>
             <a:pPr algn="ctr"/>
+            <a:endParaRPr/>
           </a:p>
         </p:txBody>
       </p:sp>
@@ -4955,6 +5028,7 @@
           <a:lstStyle/>
           <a:p>
             <a:pPr algn="ctr"/>
+            <a:endParaRPr/>
           </a:p>
         </p:txBody>
       </p:sp>
@@ -5070,6 +5144,7 @@
           <a:lstStyle/>
           <a:p>
             <a:pPr algn="ctr"/>
+            <a:endParaRPr/>
           </a:p>
         </p:txBody>
       </p:sp>
@@ -5096,7 +5171,7 @@
           <a:lstStyle/>
           <a:p>
             <a:pPr>
-              <a:defRPr b="1" sz="1100">
+              <a:defRPr sz="1100" b="1">
                 <a:solidFill>
                   <a:srgbClr val="044E29"/>
                 </a:solidFill>
@@ -5210,6 +5285,7 @@
           <a:lstStyle/>
           <a:p>
             <a:pPr algn="ctr"/>
+            <a:endParaRPr/>
           </a:p>
         </p:txBody>
       </p:sp>
@@ -5236,7 +5312,7 @@
           <a:lstStyle/>
           <a:p>
             <a:pPr>
-              <a:defRPr b="1" sz="1100">
+              <a:defRPr sz="1100" b="1">
                 <a:solidFill>
                   <a:srgbClr val="0284C7"/>
                 </a:solidFill>
@@ -5350,6 +5426,7 @@
           <a:lstStyle/>
           <a:p>
             <a:pPr algn="ctr"/>
+            <a:endParaRPr/>
           </a:p>
         </p:txBody>
       </p:sp>
@@ -5376,7 +5453,7 @@
           <a:lstStyle/>
           <a:p>
             <a:pPr>
-              <a:defRPr b="1" sz="1100">
+              <a:defRPr sz="1100" b="1">
                 <a:solidFill>
                   <a:srgbClr val="0D9488"/>
                 </a:solidFill>
@@ -5520,6 +5597,7 @@
           <a:lstStyle/>
           <a:p>
             <a:pPr algn="ctr"/>
+            <a:endParaRPr/>
           </a:p>
         </p:txBody>
       </p:sp>
@@ -5546,7 +5624,7 @@
           <a:lstStyle/>
           <a:p>
             <a:pPr>
-              <a:defRPr b="1" sz="1100">
+              <a:defRPr sz="1100" b="1">
                 <a:solidFill>
                   <a:srgbClr val="EA580C"/>
                 </a:solidFill>
@@ -5638,11 +5716,18 @@
   <p:clrMapOvr>
     <a:masterClrMapping/>
   </p:clrMapOvr>
+  <p:timing>
+    <p:tnLst>
+      <p:par>
+        <p:cTn id="1" dur="indefinite" restart="never" nodeType="tmRoot"/>
+      </p:par>
+    </p:tnLst>
+  </p:timing>
 </p:sld>
 </file>
 
 <file path=ppt/slides/slide12.xml><?xml version="1.0" encoding="utf-8"?>
-<p:sld xmlns:a="http://schemas.openxmlformats.org/drawingml/2006/main" xmlns:p="http://schemas.openxmlformats.org/presentationml/2006/main" xmlns:r="http://schemas.openxmlformats.org/officeDocument/2006/relationships">
+<p:sld xmlns:a="http://schemas.openxmlformats.org/drawingml/2006/main" xmlns:r="http://schemas.openxmlformats.org/officeDocument/2006/relationships" xmlns:p="http://schemas.openxmlformats.org/presentationml/2006/main">
   <p:cSld>
     <p:spTree>
       <p:nvGrpSpPr>
@@ -5650,7 +5735,14 @@
         <p:cNvGrpSpPr/>
         <p:nvPr/>
       </p:nvGrpSpPr>
-      <p:grpSpPr/>
+      <p:grpSpPr>
+        <a:xfrm>
+          <a:off x="0" y="0"/>
+          <a:ext cx="0" cy="0"/>
+          <a:chOff x="0" y="0"/>
+          <a:chExt cx="0" cy="0"/>
+        </a:xfrm>
+      </p:grpSpPr>
       <p:sp>
         <p:nvSpPr>
           <p:cNvPr id="2" name="Rectangle 1"/>
@@ -5691,6 +5783,7 @@
           <a:lstStyle/>
           <a:p>
             <a:pPr algn="ctr"/>
+            <a:endParaRPr/>
           </a:p>
         </p:txBody>
       </p:sp>
@@ -5734,6 +5827,7 @@
           <a:lstStyle/>
           <a:p>
             <a:pPr algn="ctr"/>
+            <a:endParaRPr/>
           </a:p>
         </p:txBody>
       </p:sp>
@@ -5850,6 +5944,7 @@
           <a:lstStyle/>
           <a:p>
             <a:pPr algn="ctr"/>
+            <a:endParaRPr/>
           </a:p>
         </p:txBody>
       </p:sp>
@@ -5862,7 +5957,7 @@
         <p:spPr>
           <a:xfrm>
             <a:off x="2468880" y="3977639"/>
-            <a:ext cx="7253935" cy="2011680"/>
+            <a:ext cx="5178021" cy="938719"/>
           </a:xfrm>
           <a:prstGeom prst="rect">
             <a:avLst/>
@@ -5876,7 +5971,7 @@
           <a:lstStyle/>
           <a:p>
             <a:r>
-              <a:rPr b="1" sz="1100">
+              <a:rPr sz="1100" b="1" dirty="0">
                 <a:solidFill>
                   <a:srgbClr val="EA580C"/>
                 </a:solidFill>
@@ -5884,17 +5979,73 @@
               <a:t>Author &amp; Presenter:       </a:t>
             </a:r>
             <a:r>
-              <a:rPr sz="1100">
+              <a:rPr sz="1100" dirty="0" err="1">
                 <a:solidFill>
                   <a:srgbClr val="FFFFFF"/>
                 </a:solidFill>
               </a:rPr>
-              <a:t>Sarath Babu Rayaprolu (Founder &amp; Lead System Architect)</a:t>
-            </a:r>
-          </a:p>
-          <a:p>
-            <a:r>
-              <a:rPr b="1" sz="1100">
+              <a:t>Sarath</a:t>
+            </a:r>
+            <a:r>
+              <a:rPr sz="1100" dirty="0">
+                <a:solidFill>
+                  <a:srgbClr val="FFFFFF"/>
+                </a:solidFill>
+              </a:rPr>
+              <a:t> </a:t>
+            </a:r>
+            <a:r>
+              <a:rPr sz="1100" dirty="0" err="1">
+                <a:solidFill>
+                  <a:srgbClr val="FFFFFF"/>
+                </a:solidFill>
+              </a:rPr>
+              <a:t>Babu</a:t>
+            </a:r>
+            <a:r>
+              <a:rPr sz="1100" dirty="0">
+                <a:solidFill>
+                  <a:srgbClr val="FFFFFF"/>
+                </a:solidFill>
+              </a:rPr>
+              <a:t> </a:t>
+            </a:r>
+            <a:r>
+              <a:rPr sz="1100" dirty="0" err="1">
+                <a:solidFill>
+                  <a:srgbClr val="FFFFFF"/>
+                </a:solidFill>
+              </a:rPr>
+              <a:t>Rayaprolu</a:t>
+            </a:r>
+            <a:r>
+              <a:rPr sz="1100" dirty="0">
+                <a:solidFill>
+                  <a:srgbClr val="FFFFFF"/>
+                </a:solidFill>
+              </a:rPr>
+              <a:t> </a:t>
+            </a:r>
+            <a:r>
+              <a:rPr sz="1100" dirty="0" smtClean="0">
+                <a:solidFill>
+                  <a:srgbClr val="FFFFFF"/>
+                </a:solidFill>
+              </a:rPr>
+              <a:t>(Lead </a:t>
+            </a:r>
+            <a:r>
+              <a:rPr sz="1100" dirty="0">
+                <a:solidFill>
+                  <a:srgbClr val="FFFFFF"/>
+                </a:solidFill>
+              </a:rPr>
+              <a:t>System Architect)</a:t>
+            </a:r>
+          </a:p>
+          <a:p>
+            <a:r>
+              <a:rPr sz="1100" b="1" dirty="0">
                 <a:solidFill>
                   <a:srgbClr val="EA580C"/>
                 </a:solidFill>
@@ -5902,7 +6053,7 @@
               <a:t>Production Web Platform:  </a:t>
             </a:r>
             <a:r>
-              <a:rPr sz="1100">
+              <a:rPr sz="1100" dirty="0">
                 <a:solidFill>
                   <a:srgbClr val="FFFFFF"/>
                 </a:solidFill>
@@ -5912,7 +6063,7 @@
           </a:p>
           <a:p>
             <a:r>
-              <a:rPr b="1" sz="1100">
+              <a:rPr sz="1100" b="1" dirty="0">
                 <a:solidFill>
                   <a:srgbClr val="EA580C"/>
                 </a:solidFill>
@@ -5920,7 +6071,7 @@
               <a:t>Live Demonstration:       </a:t>
             </a:r>
             <a:r>
-              <a:rPr sz="1100">
+              <a:rPr sz="1100" dirty="0">
                 <a:solidFill>
                   <a:srgbClr val="FFFFFF"/>
                 </a:solidFill>
@@ -5930,7 +6081,7 @@
           </a:p>
           <a:p>
             <a:r>
-              <a:rPr b="1" sz="1100">
+              <a:rPr sz="1100" b="1" dirty="0">
                 <a:solidFill>
                   <a:srgbClr val="EA580C"/>
                 </a:solidFill>
@@ -5938,7 +6089,7 @@
               <a:t>Mobile APK Build:         </a:t>
             </a:r>
             <a:r>
-              <a:rPr sz="1100">
+              <a:rPr sz="1100" dirty="0">
                 <a:solidFill>
                   <a:srgbClr val="FFFFFF"/>
                 </a:solidFill>
@@ -5948,7 +6099,7 @@
           </a:p>
           <a:p>
             <a:r>
-              <a:rPr b="1" sz="1100">
+              <a:rPr sz="1100" b="1" dirty="0">
                 <a:solidFill>
                   <a:srgbClr val="EA580C"/>
                 </a:solidFill>
@@ -5956,12 +6107,20 @@
               <a:t>Headquarters / Ops:       </a:t>
             </a:r>
             <a:r>
-              <a:rPr sz="1100">
+              <a:rPr sz="1100" dirty="0" err="1">
                 <a:solidFill>
                   <a:srgbClr val="FFFFFF"/>
                 </a:solidFill>
               </a:rPr>
-              <a:t>Bengaluru, Karnataka  |  Contact: sarath@digikavach.net</a:t>
+              <a:t>Bengaluru</a:t>
+            </a:r>
+            <a:r>
+              <a:rPr sz="1100" dirty="0">
+                <a:solidFill>
+                  <a:srgbClr val="FFFFFF"/>
+                </a:solidFill>
+              </a:rPr>
+              <a:t>, Karnataka  |  Contact: sarath@digikavach.net</a:t>
             </a:r>
           </a:p>
         </p:txBody>
@@ -5971,11 +6130,18 @@
   <p:clrMapOvr>
     <a:masterClrMapping/>
   </p:clrMapOvr>
+  <p:timing>
+    <p:tnLst>
+      <p:par>
+        <p:cTn id="1" dur="indefinite" restart="never" nodeType="tmRoot"/>
+      </p:par>
+    </p:tnLst>
+  </p:timing>
 </p:sld>
 </file>
 
 <file path=ppt/slides/slide2.xml><?xml version="1.0" encoding="utf-8"?>
-<p:sld xmlns:a="http://schemas.openxmlformats.org/drawingml/2006/main" xmlns:p="http://schemas.openxmlformats.org/presentationml/2006/main" xmlns:r="http://schemas.openxmlformats.org/officeDocument/2006/relationships">
+<p:sld xmlns:a="http://schemas.openxmlformats.org/drawingml/2006/main" xmlns:r="http://schemas.openxmlformats.org/officeDocument/2006/relationships" xmlns:p="http://schemas.openxmlformats.org/presentationml/2006/main">
   <p:cSld>
     <p:spTree>
       <p:nvGrpSpPr>
@@ -5983,7 +6149,14 @@
         <p:cNvGrpSpPr/>
         <p:nvPr/>
       </p:nvGrpSpPr>
-      <p:grpSpPr/>
+      <p:grpSpPr>
+        <a:xfrm>
+          <a:off x="0" y="0"/>
+          <a:ext cx="0" cy="0"/>
+          <a:chOff x="0" y="0"/>
+          <a:chExt cx="0" cy="0"/>
+        </a:xfrm>
+      </p:grpSpPr>
       <p:sp>
         <p:nvSpPr>
           <p:cNvPr id="2" name="Rectangle 1"/>
@@ -6024,6 +6197,7 @@
           <a:lstStyle/>
           <a:p>
             <a:pPr algn="ctr"/>
+            <a:endParaRPr/>
           </a:p>
         </p:txBody>
       </p:sp>
@@ -6174,6 +6348,7 @@
           <a:lstStyle/>
           <a:p>
             <a:pPr algn="ctr"/>
+            <a:endParaRPr/>
           </a:p>
         </p:txBody>
       </p:sp>
@@ -6289,6 +6464,7 @@
           <a:lstStyle/>
           <a:p>
             <a:pPr algn="ctr"/>
+            <a:endParaRPr/>
           </a:p>
         </p:txBody>
       </p:sp>
@@ -6315,7 +6491,7 @@
           <a:lstStyle/>
           <a:p>
             <a:pPr>
-              <a:defRPr b="1" sz="1300">
+              <a:defRPr sz="1300" b="1">
                 <a:solidFill>
                   <a:srgbClr val="B91C1C"/>
                 </a:solidFill>
@@ -6444,6 +6620,7 @@
           <a:lstStyle/>
           <a:p>
             <a:pPr algn="ctr"/>
+            <a:endParaRPr/>
           </a:p>
         </p:txBody>
       </p:sp>
@@ -6470,7 +6647,7 @@
           <a:lstStyle/>
           <a:p>
             <a:pPr>
-              <a:defRPr b="1" sz="1300">
+              <a:defRPr sz="1300" b="1">
                 <a:solidFill>
                   <a:srgbClr val="EA580C"/>
                 </a:solidFill>
@@ -6599,6 +6776,7 @@
           <a:lstStyle/>
           <a:p>
             <a:pPr algn="ctr"/>
+            <a:endParaRPr/>
           </a:p>
         </p:txBody>
       </p:sp>
@@ -6625,7 +6803,7 @@
           <a:lstStyle/>
           <a:p>
             <a:pPr>
-              <a:defRPr b="1" sz="1300">
+              <a:defRPr sz="1300" b="1">
                 <a:solidFill>
                   <a:srgbClr val="044E29"/>
                 </a:solidFill>
@@ -6717,11 +6895,18 @@
   <p:clrMapOvr>
     <a:masterClrMapping/>
   </p:clrMapOvr>
+  <p:timing>
+    <p:tnLst>
+      <p:par>
+        <p:cTn id="1" dur="indefinite" restart="never" nodeType="tmRoot"/>
+      </p:par>
+    </p:tnLst>
+  </p:timing>
 </p:sld>
 </file>
 
 <file path=ppt/slides/slide3.xml><?xml version="1.0" encoding="utf-8"?>
-<p:sld xmlns:a="http://schemas.openxmlformats.org/drawingml/2006/main" xmlns:p="http://schemas.openxmlformats.org/presentationml/2006/main" xmlns:r="http://schemas.openxmlformats.org/officeDocument/2006/relationships">
+<p:sld xmlns:a="http://schemas.openxmlformats.org/drawingml/2006/main" xmlns:r="http://schemas.openxmlformats.org/officeDocument/2006/relationships" xmlns:p="http://schemas.openxmlformats.org/presentationml/2006/main">
   <p:cSld>
     <p:spTree>
       <p:nvGrpSpPr>
@@ -6729,7 +6914,14 @@
         <p:cNvGrpSpPr/>
         <p:nvPr/>
       </p:nvGrpSpPr>
-      <p:grpSpPr/>
+      <p:grpSpPr>
+        <a:xfrm>
+          <a:off x="0" y="0"/>
+          <a:ext cx="0" cy="0"/>
+          <a:chOff x="0" y="0"/>
+          <a:chExt cx="0" cy="0"/>
+        </a:xfrm>
+      </p:grpSpPr>
       <p:sp>
         <p:nvSpPr>
           <p:cNvPr id="2" name="Rectangle 1"/>
@@ -6770,6 +6962,7 @@
           <a:lstStyle/>
           <a:p>
             <a:pPr algn="ctr"/>
+            <a:endParaRPr/>
           </a:p>
         </p:txBody>
       </p:sp>
@@ -6920,6 +7113,7 @@
           <a:lstStyle/>
           <a:p>
             <a:pPr algn="ctr"/>
+            <a:endParaRPr/>
           </a:p>
         </p:txBody>
       </p:sp>
@@ -7035,6 +7229,7 @@
           <a:lstStyle/>
           <a:p>
             <a:pPr algn="ctr"/>
+            <a:endParaRPr/>
           </a:p>
         </p:txBody>
       </p:sp>
@@ -7061,7 +7256,7 @@
           <a:lstStyle/>
           <a:p>
             <a:pPr>
-              <a:defRPr b="1" sz="1050">
+              <a:defRPr sz="1050" b="1">
                 <a:solidFill>
                   <a:srgbClr val="9A3412"/>
                 </a:solidFill>
@@ -7115,6 +7310,7 @@
           <a:lstStyle/>
           <a:p>
             <a:pPr algn="ctr"/>
+            <a:endParaRPr/>
           </a:p>
         </p:txBody>
       </p:sp>
@@ -7158,6 +7354,7 @@
           <a:lstStyle/>
           <a:p>
             <a:pPr algn="ctr"/>
+            <a:endParaRPr/>
           </a:p>
         </p:txBody>
       </p:sp>
@@ -7184,7 +7381,7 @@
           <a:lstStyle/>
           <a:p>
             <a:pPr algn="ctr">
-              <a:defRPr b="1" sz="1100">
+              <a:defRPr sz="1100" b="1">
                 <a:solidFill>
                   <a:srgbClr val="FFFFFF"/>
                 </a:solidFill>
@@ -7348,6 +7545,7 @@
           <a:lstStyle/>
           <a:p>
             <a:pPr algn="ctr"/>
+            <a:endParaRPr/>
           </a:p>
         </p:txBody>
       </p:sp>
@@ -7391,6 +7589,7 @@
           <a:lstStyle/>
           <a:p>
             <a:pPr algn="ctr"/>
+            <a:endParaRPr/>
           </a:p>
         </p:txBody>
       </p:sp>
@@ -7417,7 +7616,7 @@
           <a:lstStyle/>
           <a:p>
             <a:pPr algn="ctr">
-              <a:defRPr b="1" sz="1100">
+              <a:defRPr sz="1100" b="1">
                 <a:solidFill>
                   <a:srgbClr val="FFFFFF"/>
                 </a:solidFill>
@@ -7581,6 +7780,7 @@
           <a:lstStyle/>
           <a:p>
             <a:pPr algn="ctr"/>
+            <a:endParaRPr/>
           </a:p>
         </p:txBody>
       </p:sp>
@@ -7624,6 +7824,7 @@
           <a:lstStyle/>
           <a:p>
             <a:pPr algn="ctr"/>
+            <a:endParaRPr/>
           </a:p>
         </p:txBody>
       </p:sp>
@@ -7650,7 +7851,7 @@
           <a:lstStyle/>
           <a:p>
             <a:pPr algn="ctr">
-              <a:defRPr b="1" sz="1100">
+              <a:defRPr sz="1100" b="1">
                 <a:solidFill>
                   <a:srgbClr val="FFFFFF"/>
                 </a:solidFill>
@@ -7814,6 +8015,7 @@
           <a:lstStyle/>
           <a:p>
             <a:pPr algn="ctr"/>
+            <a:endParaRPr/>
           </a:p>
         </p:txBody>
       </p:sp>
@@ -7857,6 +8059,7 @@
           <a:lstStyle/>
           <a:p>
             <a:pPr algn="ctr"/>
+            <a:endParaRPr/>
           </a:p>
         </p:txBody>
       </p:sp>
@@ -7883,7 +8086,7 @@
           <a:lstStyle/>
           <a:p>
             <a:pPr algn="ctr">
-              <a:defRPr b="1" sz="1100">
+              <a:defRPr sz="1100" b="1">
                 <a:solidFill>
                   <a:srgbClr val="FFFFFF"/>
                 </a:solidFill>
@@ -8010,11 +8213,18 @@
   <p:clrMapOvr>
     <a:masterClrMapping/>
   </p:clrMapOvr>
+  <p:timing>
+    <p:tnLst>
+      <p:par>
+        <p:cTn id="1" dur="indefinite" restart="never" nodeType="tmRoot"/>
+      </p:par>
+    </p:tnLst>
+  </p:timing>
 </p:sld>
 </file>
 
 <file path=ppt/slides/slide4.xml><?xml version="1.0" encoding="utf-8"?>
-<p:sld xmlns:a="http://schemas.openxmlformats.org/drawingml/2006/main" xmlns:p="http://schemas.openxmlformats.org/presentationml/2006/main" xmlns:r="http://schemas.openxmlformats.org/officeDocument/2006/relationships">
+<p:sld xmlns:a="http://schemas.openxmlformats.org/drawingml/2006/main" xmlns:r="http://schemas.openxmlformats.org/officeDocument/2006/relationships" xmlns:p="http://schemas.openxmlformats.org/presentationml/2006/main">
   <p:cSld>
     <p:spTree>
       <p:nvGrpSpPr>
@@ -8022,7 +8232,14 @@
         <p:cNvGrpSpPr/>
         <p:nvPr/>
       </p:nvGrpSpPr>
-      <p:grpSpPr/>
+      <p:grpSpPr>
+        <a:xfrm>
+          <a:off x="0" y="0"/>
+          <a:ext cx="0" cy="0"/>
+          <a:chOff x="0" y="0"/>
+          <a:chExt cx="0" cy="0"/>
+        </a:xfrm>
+      </p:grpSpPr>
       <p:sp>
         <p:nvSpPr>
           <p:cNvPr id="2" name="Rectangle 1"/>
@@ -8063,6 +8280,7 @@
           <a:lstStyle/>
           <a:p>
             <a:pPr algn="ctr"/>
+            <a:endParaRPr/>
           </a:p>
         </p:txBody>
       </p:sp>
@@ -8213,6 +8431,7 @@
           <a:lstStyle/>
           <a:p>
             <a:pPr algn="ctr"/>
+            <a:endParaRPr/>
           </a:p>
         </p:txBody>
       </p:sp>
@@ -8328,6 +8547,7 @@
           <a:lstStyle/>
           <a:p>
             <a:pPr algn="ctr"/>
+            <a:endParaRPr/>
           </a:p>
         </p:txBody>
       </p:sp>
@@ -8432,6 +8652,7 @@
           <a:lstStyle/>
           <a:p>
             <a:pPr algn="ctr"/>
+            <a:endParaRPr/>
           </a:p>
         </p:txBody>
       </p:sp>
@@ -8536,6 +8757,7 @@
           <a:lstStyle/>
           <a:p>
             <a:pPr algn="ctr"/>
+            <a:endParaRPr/>
           </a:p>
         </p:txBody>
       </p:sp>
@@ -8640,6 +8862,7 @@
           <a:lstStyle/>
           <a:p>
             <a:pPr algn="ctr"/>
+            <a:endParaRPr/>
           </a:p>
         </p:txBody>
       </p:sp>
@@ -8744,6 +8967,7 @@
           <a:lstStyle/>
           <a:p>
             <a:pPr algn="ctr"/>
+            <a:endParaRPr/>
           </a:p>
         </p:txBody>
       </p:sp>
@@ -8770,7 +8994,7 @@
           <a:lstStyle/>
           <a:p>
             <a:pPr>
-              <a:defRPr b="1" sz="1200">
+              <a:defRPr sz="1200" b="1">
                 <a:solidFill>
                   <a:srgbClr val="044E29"/>
                 </a:solidFill>
@@ -8974,6 +9198,7 @@
           <a:lstStyle/>
           <a:p>
             <a:pPr algn="ctr"/>
+            <a:endParaRPr/>
           </a:p>
         </p:txBody>
       </p:sp>
@@ -9000,7 +9225,7 @@
           <a:lstStyle/>
           <a:p>
             <a:pPr>
-              <a:defRPr b="1" sz="1200">
+              <a:defRPr sz="1200" b="1">
                 <a:solidFill>
                   <a:srgbClr val="EA580C"/>
                 </a:solidFill>
@@ -9092,11 +9317,18 @@
   <p:clrMapOvr>
     <a:masterClrMapping/>
   </p:clrMapOvr>
+  <p:timing>
+    <p:tnLst>
+      <p:par>
+        <p:cTn id="1" dur="indefinite" restart="never" nodeType="tmRoot"/>
+      </p:par>
+    </p:tnLst>
+  </p:timing>
 </p:sld>
 </file>
 
 <file path=ppt/slides/slide5.xml><?xml version="1.0" encoding="utf-8"?>
-<p:sld xmlns:a="http://schemas.openxmlformats.org/drawingml/2006/main" xmlns:p="http://schemas.openxmlformats.org/presentationml/2006/main" xmlns:r="http://schemas.openxmlformats.org/officeDocument/2006/relationships">
+<p:sld xmlns:a="http://schemas.openxmlformats.org/drawingml/2006/main" xmlns:r="http://schemas.openxmlformats.org/officeDocument/2006/relationships" xmlns:p="http://schemas.openxmlformats.org/presentationml/2006/main">
   <p:cSld>
     <p:spTree>
       <p:nvGrpSpPr>
@@ -9104,7 +9336,14 @@
         <p:cNvGrpSpPr/>
         <p:nvPr/>
       </p:nvGrpSpPr>
-      <p:grpSpPr/>
+      <p:grpSpPr>
+        <a:xfrm>
+          <a:off x="0" y="0"/>
+          <a:ext cx="0" cy="0"/>
+          <a:chOff x="0" y="0"/>
+          <a:chExt cx="0" cy="0"/>
+        </a:xfrm>
+      </p:grpSpPr>
       <p:sp>
         <p:nvSpPr>
           <p:cNvPr id="2" name="Rectangle 1"/>
@@ -9145,6 +9384,7 @@
           <a:lstStyle/>
           <a:p>
             <a:pPr algn="ctr"/>
+            <a:endParaRPr/>
           </a:p>
         </p:txBody>
       </p:sp>
@@ -9295,6 +9535,7 @@
           <a:lstStyle/>
           <a:p>
             <a:pPr algn="ctr"/>
+            <a:endParaRPr/>
           </a:p>
         </p:txBody>
       </p:sp>
@@ -9410,6 +9651,7 @@
           <a:lstStyle/>
           <a:p>
             <a:pPr algn="ctr"/>
+            <a:endParaRPr/>
           </a:p>
         </p:txBody>
       </p:sp>
@@ -9453,6 +9695,7 @@
           <a:lstStyle/>
           <a:p>
             <a:pPr algn="ctr"/>
+            <a:endParaRPr/>
           </a:p>
         </p:txBody>
       </p:sp>
@@ -9479,7 +9722,7 @@
           <a:lstStyle/>
           <a:p>
             <a:pPr algn="ctr">
-              <a:defRPr b="1" sz="1050">
+              <a:defRPr sz="1050" b="1">
                 <a:solidFill>
                   <a:srgbClr val="FFFFFF"/>
                 </a:solidFill>
@@ -9643,6 +9886,7 @@
           <a:lstStyle/>
           <a:p>
             <a:pPr algn="ctr"/>
+            <a:endParaRPr/>
           </a:p>
         </p:txBody>
       </p:sp>
@@ -9686,6 +9930,7 @@
           <a:lstStyle/>
           <a:p>
             <a:pPr algn="ctr"/>
+            <a:endParaRPr/>
           </a:p>
         </p:txBody>
       </p:sp>
@@ -9712,7 +9957,7 @@
           <a:lstStyle/>
           <a:p>
             <a:pPr algn="ctr">
-              <a:defRPr b="1" sz="1050">
+              <a:defRPr sz="1050" b="1">
                 <a:solidFill>
                   <a:srgbClr val="FFFFFF"/>
                 </a:solidFill>
@@ -9876,6 +10121,7 @@
           <a:lstStyle/>
           <a:p>
             <a:pPr algn="ctr"/>
+            <a:endParaRPr/>
           </a:p>
         </p:txBody>
       </p:sp>
@@ -9919,6 +10165,7 @@
           <a:lstStyle/>
           <a:p>
             <a:pPr algn="ctr"/>
+            <a:endParaRPr/>
           </a:p>
         </p:txBody>
       </p:sp>
@@ -9945,7 +10192,7 @@
           <a:lstStyle/>
           <a:p>
             <a:pPr algn="ctr">
-              <a:defRPr b="1" sz="1050">
+              <a:defRPr sz="1050" b="1">
                 <a:solidFill>
                   <a:srgbClr val="FFFFFF"/>
                 </a:solidFill>
@@ -10072,11 +10319,18 @@
   <p:clrMapOvr>
     <a:masterClrMapping/>
   </p:clrMapOvr>
+  <p:timing>
+    <p:tnLst>
+      <p:par>
+        <p:cTn id="1" dur="indefinite" restart="never" nodeType="tmRoot"/>
+      </p:par>
+    </p:tnLst>
+  </p:timing>
 </p:sld>
 </file>
 
 <file path=ppt/slides/slide6.xml><?xml version="1.0" encoding="utf-8"?>
-<p:sld xmlns:a="http://schemas.openxmlformats.org/drawingml/2006/main" xmlns:p="http://schemas.openxmlformats.org/presentationml/2006/main" xmlns:r="http://schemas.openxmlformats.org/officeDocument/2006/relationships">
+<p:sld xmlns:a="http://schemas.openxmlformats.org/drawingml/2006/main" xmlns:r="http://schemas.openxmlformats.org/officeDocument/2006/relationships" xmlns:p="http://schemas.openxmlformats.org/presentationml/2006/main">
   <p:cSld>
     <p:spTree>
       <p:nvGrpSpPr>
@@ -10084,7 +10338,14 @@
         <p:cNvGrpSpPr/>
         <p:nvPr/>
       </p:nvGrpSpPr>
-      <p:grpSpPr/>
+      <p:grpSpPr>
+        <a:xfrm>
+          <a:off x="0" y="0"/>
+          <a:ext cx="0" cy="0"/>
+          <a:chOff x="0" y="0"/>
+          <a:chExt cx="0" cy="0"/>
+        </a:xfrm>
+      </p:grpSpPr>
       <p:sp>
         <p:nvSpPr>
           <p:cNvPr id="2" name="Rectangle 1"/>
@@ -10125,6 +10386,7 @@
           <a:lstStyle/>
           <a:p>
             <a:pPr algn="ctr"/>
+            <a:endParaRPr/>
           </a:p>
         </p:txBody>
       </p:sp>
@@ -10275,6 +10537,7 @@
           <a:lstStyle/>
           <a:p>
             <a:pPr algn="ctr"/>
+            <a:endParaRPr/>
           </a:p>
         </p:txBody>
       </p:sp>
@@ -10390,6 +10653,7 @@
           <a:lstStyle/>
           <a:p>
             <a:pPr algn="ctr"/>
+            <a:endParaRPr/>
           </a:p>
         </p:txBody>
       </p:sp>
@@ -10416,7 +10680,7 @@
           <a:lstStyle/>
           <a:p>
             <a:pPr>
-              <a:defRPr b="1" sz="1150">
+              <a:defRPr sz="1150" b="1">
                 <a:solidFill>
                   <a:srgbClr val="044E29"/>
                 </a:solidFill>
@@ -10545,6 +10809,7 @@
           <a:lstStyle/>
           <a:p>
             <a:pPr algn="ctr"/>
+            <a:endParaRPr/>
           </a:p>
         </p:txBody>
       </p:sp>
@@ -10571,7 +10836,7 @@
           <a:lstStyle/>
           <a:p>
             <a:pPr>
-              <a:defRPr b="1" sz="1150">
+              <a:defRPr sz="1150" b="1">
                 <a:solidFill>
                   <a:srgbClr val="0D9488"/>
                 </a:solidFill>
@@ -10700,6 +10965,7 @@
           <a:lstStyle/>
           <a:p>
             <a:pPr algn="ctr"/>
+            <a:endParaRPr/>
           </a:p>
         </p:txBody>
       </p:sp>
@@ -10726,7 +10992,7 @@
           <a:lstStyle/>
           <a:p>
             <a:pPr>
-              <a:defRPr b="1" sz="1150">
+              <a:defRPr sz="1150" b="1">
                 <a:solidFill>
                   <a:srgbClr val="0284C7"/>
                 </a:solidFill>
@@ -10855,6 +11121,7 @@
           <a:lstStyle/>
           <a:p>
             <a:pPr algn="ctr"/>
+            <a:endParaRPr/>
           </a:p>
         </p:txBody>
       </p:sp>
@@ -10881,7 +11148,7 @@
           <a:lstStyle/>
           <a:p>
             <a:pPr>
-              <a:defRPr b="1" sz="1150">
+              <a:defRPr sz="1150" b="1">
                 <a:solidFill>
                   <a:srgbClr val="EA580C"/>
                 </a:solidFill>
@@ -10973,11 +11240,18 @@
   <p:clrMapOvr>
     <a:masterClrMapping/>
   </p:clrMapOvr>
+  <p:timing>
+    <p:tnLst>
+      <p:par>
+        <p:cTn id="1" dur="indefinite" restart="never" nodeType="tmRoot"/>
+      </p:par>
+    </p:tnLst>
+  </p:timing>
 </p:sld>
 </file>
 
 <file path=ppt/slides/slide7.xml><?xml version="1.0" encoding="utf-8"?>
-<p:sld xmlns:a="http://schemas.openxmlformats.org/drawingml/2006/main" xmlns:p="http://schemas.openxmlformats.org/presentationml/2006/main" xmlns:r="http://schemas.openxmlformats.org/officeDocument/2006/relationships">
+<p:sld xmlns:a="http://schemas.openxmlformats.org/drawingml/2006/main" xmlns:r="http://schemas.openxmlformats.org/officeDocument/2006/relationships" xmlns:p="http://schemas.openxmlformats.org/presentationml/2006/main">
   <p:cSld>
     <p:spTree>
       <p:nvGrpSpPr>
@@ -10985,7 +11259,14 @@
         <p:cNvGrpSpPr/>
         <p:nvPr/>
       </p:nvGrpSpPr>
-      <p:grpSpPr/>
+      <p:grpSpPr>
+        <a:xfrm>
+          <a:off x="0" y="0"/>
+          <a:ext cx="0" cy="0"/>
+          <a:chOff x="0" y="0"/>
+          <a:chExt cx="0" cy="0"/>
+        </a:xfrm>
+      </p:grpSpPr>
       <p:sp>
         <p:nvSpPr>
           <p:cNvPr id="2" name="Rectangle 1"/>
@@ -11026,6 +11307,7 @@
           <a:lstStyle/>
           <a:p>
             <a:pPr algn="ctr"/>
+            <a:endParaRPr/>
           </a:p>
         </p:txBody>
       </p:sp>
@@ -11176,6 +11458,7 @@
           <a:lstStyle/>
           <a:p>
             <a:pPr algn="ctr"/>
+            <a:endParaRPr/>
           </a:p>
         </p:txBody>
       </p:sp>
@@ -11883,6 +12166,7 @@
           <a:lstStyle/>
           <a:p>
             <a:pPr algn="ctr"/>
+            <a:endParaRPr/>
           </a:p>
         </p:txBody>
       </p:sp>
@@ -11909,7 +12193,7 @@
           <a:lstStyle/>
           <a:p>
             <a:pPr>
-              <a:defRPr b="1" sz="1300">
+              <a:defRPr sz="1300" b="1">
                 <a:solidFill>
                   <a:srgbClr val="044E29"/>
                 </a:solidFill>
@@ -11926,7 +12210,7 @@
               </a:spcAft>
             </a:pPr>
             <a:r>
-              <a:rPr b="1" sz="950">
+              <a:rPr sz="950" b="1">
                 <a:solidFill>
                   <a:srgbClr val="EA580C"/>
                 </a:solidFill>
@@ -11949,7 +12233,7 @@
               </a:spcAft>
             </a:pPr>
             <a:r>
-              <a:rPr b="1" sz="950">
+              <a:rPr sz="950" b="1">
                 <a:solidFill>
                   <a:srgbClr val="EA580C"/>
                 </a:solidFill>
@@ -11972,7 +12256,7 @@
               </a:spcAft>
             </a:pPr>
             <a:r>
-              <a:rPr b="1" sz="950">
+              <a:rPr sz="950" b="1">
                 <a:solidFill>
                   <a:srgbClr val="EA580C"/>
                 </a:solidFill>
@@ -11995,7 +12279,7 @@
               </a:spcAft>
             </a:pPr>
             <a:r>
-              <a:rPr b="1" sz="950">
+              <a:rPr sz="950" b="1">
                 <a:solidFill>
                   <a:srgbClr val="EA580C"/>
                 </a:solidFill>
@@ -12018,7 +12302,7 @@
               </a:spcAft>
             </a:pPr>
             <a:r>
-              <a:rPr b="1" sz="950">
+              <a:rPr sz="950" b="1">
                 <a:solidFill>
                   <a:srgbClr val="EA580C"/>
                 </a:solidFill>
@@ -12078,6 +12362,7 @@
           <a:lstStyle/>
           <a:p>
             <a:pPr algn="ctr"/>
+            <a:endParaRPr/>
           </a:p>
         </p:txBody>
       </p:sp>
@@ -12104,7 +12389,7 @@
           <a:lstStyle/>
           <a:p>
             <a:pPr>
-              <a:defRPr b="1" sz="1100">
+              <a:defRPr sz="1100" b="1">
                 <a:solidFill>
                   <a:srgbClr val="044E29"/>
                 </a:solidFill>
@@ -12181,11 +12466,18 @@
   <p:clrMapOvr>
     <a:masterClrMapping/>
   </p:clrMapOvr>
+  <p:timing>
+    <p:tnLst>
+      <p:par>
+        <p:cTn id="1" dur="indefinite" restart="never" nodeType="tmRoot"/>
+      </p:par>
+    </p:tnLst>
+  </p:timing>
 </p:sld>
 </file>
 
 <file path=ppt/slides/slide8.xml><?xml version="1.0" encoding="utf-8"?>
-<p:sld xmlns:a="http://schemas.openxmlformats.org/drawingml/2006/main" xmlns:p="http://schemas.openxmlformats.org/presentationml/2006/main" xmlns:r="http://schemas.openxmlformats.org/officeDocument/2006/relationships">
+<p:sld xmlns:a="http://schemas.openxmlformats.org/drawingml/2006/main" xmlns:r="http://schemas.openxmlformats.org/officeDocument/2006/relationships" xmlns:p="http://schemas.openxmlformats.org/presentationml/2006/main">
   <p:cSld>
     <p:spTree>
       <p:nvGrpSpPr>
@@ -12193,7 +12485,14 @@
         <p:cNvGrpSpPr/>
         <p:nvPr/>
       </p:nvGrpSpPr>
-      <p:grpSpPr/>
+      <p:grpSpPr>
+        <a:xfrm>
+          <a:off x="0" y="0"/>
+          <a:ext cx="0" cy="0"/>
+          <a:chOff x="0" y="0"/>
+          <a:chExt cx="0" cy="0"/>
+        </a:xfrm>
+      </p:grpSpPr>
       <p:sp>
         <p:nvSpPr>
           <p:cNvPr id="2" name="Rectangle 1"/>
@@ -12234,6 +12533,7 @@
           <a:lstStyle/>
           <a:p>
             <a:pPr algn="ctr"/>
+            <a:endParaRPr/>
           </a:p>
         </p:txBody>
       </p:sp>
@@ -12384,6 +12684,7 @@
           <a:lstStyle/>
           <a:p>
             <a:pPr algn="ctr"/>
+            <a:endParaRPr/>
           </a:p>
         </p:txBody>
       </p:sp>
@@ -12499,6 +12800,7 @@
           <a:lstStyle/>
           <a:p>
             <a:pPr algn="ctr"/>
+            <a:endParaRPr/>
           </a:p>
         </p:txBody>
       </p:sp>
@@ -12542,6 +12844,7 @@
           <a:lstStyle/>
           <a:p>
             <a:pPr algn="ctr"/>
+            <a:endParaRPr/>
           </a:p>
         </p:txBody>
       </p:sp>
@@ -12568,7 +12871,7 @@
           <a:lstStyle/>
           <a:p>
             <a:pPr algn="ctr">
-              <a:defRPr b="1" sz="1050">
+              <a:defRPr sz="1050" b="1">
                 <a:solidFill>
                   <a:srgbClr val="FFFFFF"/>
                 </a:solidFill>
@@ -12717,6 +13020,7 @@
           <a:lstStyle/>
           <a:p>
             <a:pPr algn="ctr"/>
+            <a:endParaRPr/>
           </a:p>
         </p:txBody>
       </p:sp>
@@ -12760,6 +13064,7 @@
           <a:lstStyle/>
           <a:p>
             <a:pPr algn="ctr"/>
+            <a:endParaRPr/>
           </a:p>
         </p:txBody>
       </p:sp>
@@ -12786,7 +13091,7 @@
           <a:lstStyle/>
           <a:p>
             <a:pPr algn="ctr">
-              <a:defRPr b="1" sz="1050">
+              <a:defRPr sz="1050" b="1">
                 <a:solidFill>
                   <a:srgbClr val="FFFFFF"/>
                 </a:solidFill>
@@ -12935,6 +13240,7 @@
           <a:lstStyle/>
           <a:p>
             <a:pPr algn="ctr"/>
+            <a:endParaRPr/>
           </a:p>
         </p:txBody>
       </p:sp>
@@ -12978,6 +13284,7 @@
           <a:lstStyle/>
           <a:p>
             <a:pPr algn="ctr"/>
+            <a:endParaRPr/>
           </a:p>
         </p:txBody>
       </p:sp>
@@ -13004,7 +13311,7 @@
           <a:lstStyle/>
           <a:p>
             <a:pPr algn="ctr">
-              <a:defRPr b="1" sz="1050">
+              <a:defRPr sz="1050" b="1">
                 <a:solidFill>
                   <a:srgbClr val="FFFFFF"/>
                 </a:solidFill>
@@ -13116,11 +13423,18 @@
   <p:clrMapOvr>
     <a:masterClrMapping/>
   </p:clrMapOvr>
+  <p:timing>
+    <p:tnLst>
+      <p:par>
+        <p:cTn id="1" dur="indefinite" restart="never" nodeType="tmRoot"/>
+      </p:par>
+    </p:tnLst>
+  </p:timing>
 </p:sld>
 </file>
 
 <file path=ppt/slides/slide9.xml><?xml version="1.0" encoding="utf-8"?>
-<p:sld xmlns:a="http://schemas.openxmlformats.org/drawingml/2006/main" xmlns:p="http://schemas.openxmlformats.org/presentationml/2006/main" xmlns:r="http://schemas.openxmlformats.org/officeDocument/2006/relationships">
+<p:sld xmlns:a="http://schemas.openxmlformats.org/drawingml/2006/main" xmlns:r="http://schemas.openxmlformats.org/officeDocument/2006/relationships" xmlns:p="http://schemas.openxmlformats.org/presentationml/2006/main">
   <p:cSld>
     <p:spTree>
       <p:nvGrpSpPr>
@@ -13128,7 +13442,14 @@
         <p:cNvGrpSpPr/>
         <p:nvPr/>
       </p:nvGrpSpPr>
-      <p:grpSpPr/>
+      <p:grpSpPr>
+        <a:xfrm>
+          <a:off x="0" y="0"/>
+          <a:ext cx="0" cy="0"/>
+          <a:chOff x="0" y="0"/>
+          <a:chExt cx="0" cy="0"/>
+        </a:xfrm>
+      </p:grpSpPr>
       <p:sp>
         <p:nvSpPr>
           <p:cNvPr id="2" name="Rectangle 1"/>
@@ -13169,6 +13490,7 @@
           <a:lstStyle/>
           <a:p>
             <a:pPr algn="ctr"/>
+            <a:endParaRPr/>
           </a:p>
         </p:txBody>
       </p:sp>
@@ -13319,6 +13641,7 @@
           <a:lstStyle/>
           <a:p>
             <a:pPr algn="ctr"/>
+            <a:endParaRPr/>
           </a:p>
         </p:txBody>
       </p:sp>
@@ -13434,6 +13757,7 @@
           <a:lstStyle/>
           <a:p>
             <a:pPr algn="ctr"/>
+            <a:endParaRPr/>
           </a:p>
         </p:txBody>
       </p:sp>
@@ -13460,7 +13784,7 @@
           <a:lstStyle/>
           <a:p>
             <a:pPr>
-              <a:defRPr b="1" sz="1150">
+              <a:defRPr sz="1150" b="1">
                 <a:solidFill>
                   <a:srgbClr val="044E29"/>
                 </a:solidFill>
@@ -13589,6 +13913,7 @@
           <a:lstStyle/>
           <a:p>
             <a:pPr algn="ctr"/>
+            <a:endParaRPr/>
           </a:p>
         </p:txBody>
       </p:sp>
@@ -13615,7 +13940,7 @@
           <a:lstStyle/>
           <a:p>
             <a:pPr>
-              <a:defRPr b="1" sz="1150">
+              <a:defRPr sz="1150" b="1">
                 <a:solidFill>
                   <a:srgbClr val="0D9488"/>
                 </a:solidFill>
@@ -13744,6 +14069,7 @@
           <a:lstStyle/>
           <a:p>
             <a:pPr algn="ctr"/>
+            <a:endParaRPr/>
           </a:p>
         </p:txBody>
       </p:sp>
@@ -13770,7 +14096,7 @@
           <a:lstStyle/>
           <a:p>
             <a:pPr>
-              <a:defRPr b="1" sz="1150">
+              <a:defRPr sz="1150" b="1">
                 <a:solidFill>
                   <a:srgbClr val="0284C7"/>
                 </a:solidFill>
@@ -13899,6 +14225,7 @@
           <a:lstStyle/>
           <a:p>
             <a:pPr algn="ctr"/>
+            <a:endParaRPr/>
           </a:p>
         </p:txBody>
       </p:sp>
@@ -13925,7 +14252,7 @@
           <a:lstStyle/>
           <a:p>
             <a:pPr>
-              <a:defRPr b="1" sz="1150">
+              <a:defRPr sz="1150" b="1">
                 <a:solidFill>
                   <a:srgbClr val="EA580C"/>
                 </a:solidFill>
@@ -14017,6 +14344,13 @@
   <p:clrMapOvr>
     <a:masterClrMapping/>
   </p:clrMapOvr>
+  <p:timing>
+    <p:tnLst>
+      <p:par>
+        <p:cTn id="1" dur="indefinite" restart="never" nodeType="tmRoot"/>
+      </p:par>
+    </p:tnLst>
+  </p:timing>
 </p:sld>
 </file>
 

</xml_diff>